<commit_message>
Consolidate highlighted decks into one final BDC presentation
Made-with: Cursor
</commit_message>
<xml_diff>
--- a/slides/export/Archive_of_Extinction_Final_BDC2026.pptx
+++ b/slides/export/Archive_of_Extinction_Final_BDC2026.pptx
@@ -22,6 +22,10 @@
     <p:sldId id="270" r:id="rId21"/>
     <p:sldId id="271" r:id="rId22"/>
     <p:sldId id="272" r:id="rId23"/>
+    <p:sldId id="273" r:id="rId24"/>
+    <p:sldId id="274" r:id="rId25"/>
+    <p:sldId id="275" r:id="rId26"/>
+    <p:sldId id="276" r:id="rId27"/>
   </p:sldIdLst>
   <p:sldSz cx="12191695" cy="6858000" type="screen4x3"/>
   <p:notesSz cx="6858000" cy="9144000"/>
@@ -3120,7 +3124,7 @@
           <a:lstStyle/>
           <a:p>
             <a:r>
-              <a:t>Archive of Extinction</a:t>
+              <a:t>Archive of Extinction: AI Memorial for Lost Species</a:t>
             </a:r>
           </a:p>
         </p:txBody>
@@ -3141,12 +3145,7 @@
           <a:lstStyle/>
           <a:p>
             <a:r>
-              <a:t>Environmental Hypothesis Dossiers</a:t>
-            </a:r>
-          </a:p>
-          <a:p>
-            <a:r>
-              <a:t>An AI Memorial for Lost Species - Sensory Time Capsule</a:t>
+              <a:t>Umwelt Hypothesis Dossiers / Sensory Time Capsule</a:t>
             </a:r>
           </a:p>
           <a:p>
@@ -3195,7 +3194,7 @@
           <a:lstStyle/>
           <a:p>
             <a:r>
-              <a:t>Two species - two dossiers</a:t>
+              <a:t>User journey &amp; scene flow</a:t>
             </a:r>
           </a:p>
         </p:txBody>
@@ -3207,91 +3206,43 @@
             <a:spLocks noGrp="1"/>
           </p:cNvSpPr>
           <p:nvPr>
-            <p:ph idx="1" sz="half"/>
-          </p:nvPr>
-        </p:nvSpPr>
-        <p:spPr/>
-        <p:txBody>
-          <a:bodyPr/>
-          <a:lstStyle/>
-          <a:p>
-            <a:pPr>
-              <a:defRPr b="1" sz="1400"/>
-            </a:pPr>
-            <a:r>
-              <a:t>Woolly mammoth</a:t>
-            </a:r>
-          </a:p>
-          <a:p>
-            <a:pPr>
-              <a:defRPr sz="1300"/>
-            </a:pPr>
-            <a:r>
-              <a:t>Arctic rhythm + mammoth steppe; scenes Scene_Bio_01 - Scene_Sensory_01.</a:t>
-            </a:r>
-          </a:p>
-          <a:p>
-            <a:pPr>
-              <a:defRPr sz="1300"/>
-            </a:pPr>
-            <a:r>
-              <a:t>Lynch 2015 circadian-related genes; Lu 2010 reindeer [Interpolated]; Zimov 2012 habitat.</a:t>
-            </a:r>
-          </a:p>
-          <a:p>
-            <a:pPr>
-              <a:defRPr sz="1300"/>
-            </a:pPr>
-            <a:r>
-              <a:t>TRPV3: Lynch 2015 primary; Kim 2017 bioRxiv optional + labeled.</a:t>
-            </a:r>
-          </a:p>
-        </p:txBody>
-      </p:sp>
-      <p:sp>
-        <p:nvSpPr>
-          <p:cNvPr id="4" name="Content Placeholder 3"/>
-          <p:cNvSpPr>
-            <a:spLocks noGrp="1"/>
-          </p:cNvSpPr>
-          <p:nvPr>
-            <p:ph idx="2" sz="half"/>
-          </p:nvPr>
-        </p:nvSpPr>
-        <p:spPr/>
-        <p:txBody>
-          <a:bodyPr/>
-          <a:lstStyle/>
-          <a:p>
-            <a:pPr>
-              <a:defRPr b="1" sz="1400"/>
-            </a:pPr>
-            <a:r>
-              <a:t>Thylacine</a:t>
-            </a:r>
-          </a:p>
-          <a:p>
-            <a:pPr>
-              <a:defRPr sz="1300"/>
-            </a:pPr>
-            <a:r>
-              <a:t>Crepuscular / night vision metaphor; colonial context mandatory.</a:t>
-            </a:r>
-          </a:p>
-          <a:p>
-            <a:pPr>
-              <a:defRPr sz="1300"/>
-            </a:pPr>
-            <a:r>
-              <a:t>Pozniak 2018 orbit; Mass &amp; Supin 2020 RGC [Interpolated]; Paddle; Sleightholme &amp; Campbell.</a:t>
-            </a:r>
-          </a:p>
-          <a:p>
-            <a:pPr>
-              <a:defRPr sz="1300"/>
-            </a:pPr>
-            <a:r>
-              <a:t>T5: Clements + Palawa: Rimmer, Lehman; Schlunke 2025.</a:t>
+            <p:ph idx="1"/>
+          </p:nvPr>
+        </p:nvSpPr>
+        <p:spPr/>
+        <p:txBody>
+          <a:bodyPr/>
+          <a:lstStyle/>
+          <a:p>
+            <a:pPr>
+              <a:defRPr sz="1600"/>
+            </a:pPr>
+            <a:r>
+              <a:t>Mammoth path: Scene_Bio_01 -&gt; Scene_Environment_02 -&gt; Scene_Landscape_01 -&gt; Scene_Sensory_01.</a:t>
+            </a:r>
+          </a:p>
+          <a:p>
+            <a:pPr>
+              <a:defRPr sz="1600"/>
+            </a:pPr>
+            <a:r>
+              <a:t>Thylacine path: Scene_Bio_02 -&gt; Scene_POV_01 -&gt; Scene_Context_01.</a:t>
+            </a:r>
+          </a:p>
+          <a:p>
+            <a:pPr>
+              <a:defRPr sz="1600"/>
+            </a:pPr>
+            <a:r>
+              <a:t>Shared modules: UI_Indigenous_Context -&gt; UI_Ethics_Fork -&gt; UI_Reflection_Log.</a:t>
+            </a:r>
+          </a:p>
+          <a:p>
+            <a:pPr>
+              <a:defRPr sz="1600"/>
+            </a:pPr>
+            <a:r>
+              <a:t>All three load-bearing modules ship in the MVP: Dossier -&gt; Mixer -&gt; Ethics.</a:t>
             </a:r>
           </a:p>
         </p:txBody>
@@ -3330,7 +3281,7 @@
           <a:lstStyle/>
           <a:p>
             <a:r>
-              <a:t>Experience architecture (scene IDs)</a:t>
+              <a:t>Methods &amp; evidence protocol</a:t>
             </a:r>
           </a:p>
         </p:txBody>
@@ -3354,23 +3305,31 @@
               <a:defRPr sz="1600"/>
             </a:pPr>
             <a:r>
-              <a:t>Mammoth: Scene_Bio_01 -&gt; Scene_Environment_02 -&gt; Scene_Landscape_01 -&gt; Scene_Sensory_01.</a:t>
-            </a:r>
-          </a:p>
-          <a:p>
-            <a:pPr>
-              <a:defRPr sz="1600"/>
-            </a:pPr>
-            <a:r>
-              <a:t>Thylacine: Scene_Bio_02 -&gt; Scene_POV_01 -&gt; Scene_Context_01.</a:t>
-            </a:r>
-          </a:p>
-          <a:p>
-            <a:pPr>
-              <a:defRPr sz="1600"/>
-            </a:pPr>
-            <a:r>
-              <a:t>Shared: UI_Indigenous_Context -&gt; UI_Ethics_Fork -&gt; UI_Reflection_Log.</a:t>
+              <a:t>Claims are imported to structured cards / JSON; each block is labeled Cited / Modeled / Speculative.</a:t>
+            </a:r>
+          </a:p>
+          <a:p>
+            <a:pPr>
+              <a:defRPr sz="1600"/>
+            </a:pPr>
+            <a:r>
+              <a:t>Science visuals can include ggplot2 stills for tusk isotope summaries and time-series evidence panels.</a:t>
+            </a:r>
+          </a:p>
+          <a:p>
+            <a:pPr>
+              <a:defRPr sz="1600"/>
+            </a:pPr>
+            <a:r>
+              <a:t>Generative runs log model, date, and seed where relevant; DSP rules are documented rather than hidden.</a:t>
+            </a:r>
+          </a:p>
+          <a:p>
+            <a:pPr>
+              <a:defRPr sz="1600"/>
+            </a:pPr>
+            <a:r>
+              <a:t>Process includes at least two evidence audits during production to remove unlabeled claims.</a:t>
             </a:r>
           </a:p>
         </p:txBody>
@@ -3409,7 +3368,7 @@
           <a:lstStyle/>
           <a:p>
             <a:r>
-              <a:t>Literature - Mammoth slots M1-M5</a:t>
+              <a:t>Ethics, colonial violence &amp; ecological memory</a:t>
             </a:r>
           </a:p>
         </p:txBody>
@@ -3433,39 +3392,31 @@
               <a:defRPr sz="1600"/>
             </a:pPr>
             <a:r>
-              <a:t>M1 Lynch et al. 2015 Cell Rep 10.1016/j.celrep.2015.06.027</a:t>
-            </a:r>
-          </a:p>
-          <a:p>
-            <a:pPr>
-              <a:defRPr sz="1600"/>
-            </a:pPr>
-            <a:r>
-              <a:t>M2 Lu et al. 2010 Curr Biol 10.1016/j.cub.2010.01.042</a:t>
-            </a:r>
-          </a:p>
-          <a:p>
-            <a:pPr>
-              <a:defRPr sz="1600"/>
-            </a:pPr>
-            <a:r>
-              <a:t>M3 Zimov et al. 2012 QSR 10.1016/j.quascirev.2012.08.004</a:t>
-            </a:r>
-          </a:p>
-          <a:p>
-            <a:pPr>
-              <a:defRPr sz="1600"/>
-            </a:pPr>
-            <a:r>
-              <a:t>M4 Kim et al. 2017 bioRxiv 10.1101/151746 (preprint)</a:t>
-            </a:r>
-          </a:p>
-          <a:p>
-            <a:pPr>
-              <a:defRPr sz="1600"/>
-            </a:pPr>
-            <a:r>
-              <a:t>M5 Sherkow &amp; Greely 2013 Science 10.1126/science.1236946</a:t>
+              <a:t>Sherkow &amp; Greely (2013): trade-offs between laboratory de-extinction, in situ conservation, legal novelty, and ecological liability.</a:t>
+            </a:r>
+          </a:p>
+          <a:p>
+            <a:pPr>
+              <a:defRPr sz="1600"/>
+            </a:pPr>
+            <a:r>
+              <a:t>Thylacine loss is entangled with violence against Palawa peoples and Country in lutruwita / Tasmania.</a:t>
+            </a:r>
+          </a:p>
+          <a:p>
+            <a:pPr>
+              <a:defRPr sz="1600"/>
+            </a:pPr>
+            <a:r>
+              <a:t>Interface protocol: Palawa-first voices where possible; author positionality is explicit; no tourism copy as TEK.</a:t>
+            </a:r>
+          </a:p>
+          <a:p>
+            <a:pPr>
+              <a:defRPr sz="1600"/>
+            </a:pPr>
+            <a:r>
+              <a:t>The archive is remembrance and accountability, not resurrection spectacle.</a:t>
             </a:r>
           </a:p>
         </p:txBody>
@@ -3504,7 +3455,7 @@
           <a:lstStyle/>
           <a:p>
             <a:r>
-              <a:t>Literature - Thylacine T1-T5 + sovereignty</a:t>
+              <a:t>Ideation &amp; design process</a:t>
             </a:r>
           </a:p>
         </p:txBody>
@@ -3528,31 +3479,23 @@
               <a:defRPr sz="1600"/>
             </a:pPr>
             <a:r>
-              <a:t>T1 Pozniak 2018 10.1002/ar.23910 | T2 Mass &amp; Supin 2020 10.31857/S0002332920060107</a:t>
-            </a:r>
-          </a:p>
-          <a:p>
-            <a:pPr>
-              <a:defRPr sz="1600"/>
-            </a:pPr>
-            <a:r>
-              <a:t>T3 Paddle 2000 ISBN 9780521782196 | T4 Sleightholme &amp; Campbell 2016 10.1080/00222933.2016.1217037</a:t>
-            </a:r>
-          </a:p>
-          <a:p>
-            <a:pPr>
-              <a:defRPr sz="1600"/>
-            </a:pPr>
-            <a:r>
-              <a:t>T5 Clements 2025 10.1177/13534858251272203</a:t>
-            </a:r>
-          </a:p>
-          <a:p>
-            <a:pPr>
-              <a:defRPr sz="1600"/>
-            </a:pPr>
-            <a:r>
-              <a:t>Palawa: Rimmer 2020 Artlink | Lehman 2013 Griffith Review | Schlunke 2025 10.1017/ext.2025.10008</a:t>
+              <a:t>1 Map skills -&gt; 2 Intersection statements -&gt; 3 Rubric stress-test -&gt; 4 Biology sprint.</a:t>
+            </a:r>
+          </a:p>
+          <a:p>
+            <a:pPr>
+              <a:defRPr sz="1600"/>
+            </a:pPr>
+            <a:r>
+              <a:t>5 Bio / digital split -&gt; 6 Narrative draft -&gt; 7 Prototype + deliverables -&gt; 8 Build / polish / Q&amp;A.</a:t>
+            </a:r>
+          </a:p>
+          <a:p>
+            <a:pPr>
+              <a:defRPr sz="1600"/>
+            </a:pPr>
+            <a:r>
+              <a:t>This process is aligned with the course workbook, biodesign_cursor_agent.md, and BDC judging logic.</a:t>
             </a:r>
           </a:p>
         </p:txBody>
@@ -3591,7 +3534,7 @@
           <a:lstStyle/>
           <a:p>
             <a:r>
-              <a:t>BDC rubric self-assessment</a:t>
+              <a:t>Production plan (4-week spine)</a:t>
             </a:r>
           </a:p>
         </p:txBody>
@@ -3615,31 +3558,31 @@
               <a:defRPr sz="1600"/>
             </a:pPr>
             <a:r>
-              <a:t>Narrative: discover rhythm -&gt; loss -&gt; ethical fork (target strong).</a:t>
-            </a:r>
-          </a:p>
-          <a:p>
-            <a:pPr>
-              <a:defRPr sz="1600"/>
-            </a:pPr>
-            <a:r>
-              <a:t>Concept: time as spine; one biological proxy per scene.</a:t>
-            </a:r>
-          </a:p>
-          <a:p>
-            <a:pPr>
-              <a:defRPr sz="1600"/>
-            </a:pPr>
-            <a:r>
-              <a:t>Context: de-extinction trade-offs + Indigenous sovereignty (expand citations).</a:t>
-            </a:r>
-          </a:p>
-          <a:p>
-            <a:pPr>
-              <a:defRPr sz="1600"/>
-            </a:pPr>
-            <a:r>
-              <a:t>Reflection: interactive epistemic UI + user reflection + AI limits disclosed.</a:t>
+              <a:t>Week 1: literature grid, storyboard, WebXR shell, evidence audit #1.</a:t>
+            </a:r>
+          </a:p>
+          <a:p>
+            <a:pPr>
+              <a:defRPr sz="1600"/>
+            </a:pPr>
+            <a:r>
+              <a:t>Week 2: dossier UI, time scrubber, environment logic, ethics drafts, methods / limitations slide.</a:t>
+            </a:r>
+          </a:p>
+          <a:p>
+            <a:pPr>
+              <a:defRPr sz="1600"/>
+            </a:pPr>
+            <a:r>
+              <a:t>Week 3: integrate thylacine context, reflection panel, sonification, evidence audit #2.</a:t>
+            </a:r>
+          </a:p>
+          <a:p>
+            <a:pPr>
+              <a:defRPr sz="1600"/>
+            </a:pPr>
+            <a:r>
+              <a:t>Week 4: polish, accessibility, P0 bugs only, 10-min talk, 5-min Q&amp;A, trailer export.</a:t>
             </a:r>
           </a:p>
         </p:txBody>
@@ -3678,7 +3621,7 @@
           <a:lstStyle/>
           <a:p>
             <a:r>
-              <a:t>Deliverables &amp; physical strategy</a:t>
+              <a:t>Biodesign Challenge fit</a:t>
             </a:r>
           </a:p>
         </p:txBody>
@@ -3702,23 +3645,31 @@
               <a:defRPr sz="1600"/>
             </a:pPr>
             <a:r>
-              <a:t>10 min talk + 5 min Q&amp;A; 1-5 min creative video; slides to Drive.</a:t>
-            </a:r>
-          </a:p>
-          <a:p>
-            <a:pPr>
-              <a:defRPr sz="1600"/>
-            </a:pPr>
-            <a:r>
-              <a:t>Visuals + WebXR; minimal tactile anchor + QR (no wet-lab for v1).</a:t>
-            </a:r>
-          </a:p>
-          <a:p>
-            <a:pPr>
-              <a:defRPr sz="1600"/>
-            </a:pPr>
-            <a:r>
-              <a:t>Planning source of truth: BDC_2026_Extinction_Archive_Planning_Document.md + PROJECT_PLAN.md.</a:t>
+              <a:t>Narrative: clear emotional and spatial journey supported by live digital demo.</a:t>
+            </a:r>
+          </a:p>
+          <a:p>
+            <a:pPr>
+              <a:defRPr sz="1600"/>
+            </a:pPr>
+            <a:r>
+              <a:t>Concept: temporal niche + Umwelt + evidence literacy creates a distinct biodigital proposition.</a:t>
+            </a:r>
+          </a:p>
+          <a:p>
+            <a:pPr>
+              <a:defRPr sz="1600"/>
+            </a:pPr>
+            <a:r>
+              <a:t>Context: biodiversity loss, de-extinction ethics, misinformation risk, and Indigenous sovereignty.</a:t>
+            </a:r>
+          </a:p>
+          <a:p>
+            <a:pPr>
+              <a:defRPr sz="1600"/>
+            </a:pPr>
+            <a:r>
+              <a:t>Reflection: documented limitations, epistemic layers, prompt / model logging, user reflection.</a:t>
             </a:r>
           </a:p>
         </p:txBody>
@@ -3757,7 +3708,7 @@
           <a:lstStyle/>
           <a:p>
             <a:r>
-              <a:t>Risks we mitigate</a:t>
+              <a:t>Deliverables &amp; summit package</a:t>
             </a:r>
           </a:p>
         </p:txBody>
@@ -3781,23 +3732,31 @@
               <a:defRPr sz="1600"/>
             </a:pPr>
             <a:r>
-              <a:t>"Just VR art" - always show citation strip.</a:t>
-            </a:r>
-          </a:p>
-          <a:p>
-            <a:pPr>
-              <a:defRPr sz="1600"/>
-            </a:pPr>
-            <a:r>
-              <a:t>Overclaiming PER2 - UI uses circadian-related genes until PDF verified.</a:t>
-            </a:r>
-          </a:p>
-          <a:p>
-            <a:pPr>
-              <a:defRPr sz="1600"/>
-            </a:pPr>
-            <a:r>
-              <a:t>Token TEK - Palawa-led sources + positionality statement.</a:t>
+              <a:t>10-minute oral presentation + 5-minute Q&amp;A.</a:t>
+            </a:r>
+          </a:p>
+          <a:p>
+            <a:pPr>
+              <a:defRPr sz="1600"/>
+            </a:pPr>
+            <a:r>
+              <a:t>Visual renderings, WebXR experience, and citation-aware UI captures.</a:t>
+            </a:r>
+          </a:p>
+          <a:p>
+            <a:pPr>
+              <a:defRPr sz="1600"/>
+            </a:pPr>
+            <a:r>
+              <a:t>Minimal physical anchor + QR for reliable access in gallery or talk format.</a:t>
+            </a:r>
+          </a:p>
+          <a:p>
+            <a:pPr>
+              <a:defRPr sz="1600"/>
+            </a:pPr>
+            <a:r>
+              <a:t>1-5 minute creative trailer, PPT deck, methods appendix, and citations / limits in parallel.</a:t>
             </a:r>
           </a:p>
         </p:txBody>
@@ -3827,42 +3786,254 @@
             <a:spLocks noGrp="1"/>
           </p:cNvSpPr>
           <p:nvPr>
-            <p:ph type="ctrTitle"/>
-          </p:nvPr>
-        </p:nvSpPr>
-        <p:spPr/>
-        <p:txBody>
-          <a:bodyPr/>
-          <a:lstStyle/>
-          <a:p>
-            <a:r>
-              <a:t>Thank you</a:t>
-            </a:r>
-          </a:p>
-        </p:txBody>
-      </p:sp>
-      <p:sp>
-        <p:nvSpPr>
-          <p:cNvPr id="3" name="Subtitle 2"/>
-          <p:cNvSpPr>
-            <a:spLocks noGrp="1"/>
-          </p:cNvSpPr>
-          <p:nvPr>
-            <p:ph type="subTitle" idx="1"/>
-          </p:nvPr>
-        </p:nvSpPr>
-        <p:spPr/>
-        <p:txBody>
-          <a:bodyPr/>
-          <a:lstStyle/>
-          <a:p>
-            <a:r>
-              <a:t>Archive of Extinction</a:t>
-            </a:r>
-          </a:p>
-          <a:p>
-            <a:r>
-              <a:t>Questions - biodesignchallenge.org</a:t>
+            <p:ph type="title"/>
+          </p:nvPr>
+        </p:nvSpPr>
+        <p:spPr/>
+        <p:txBody>
+          <a:bodyPr/>
+          <a:lstStyle/>
+          <a:p>
+            <a:r>
+              <a:t>Key literature - mammoth dossier</a:t>
+            </a:r>
+          </a:p>
+        </p:txBody>
+      </p:sp>
+      <p:sp>
+        <p:nvSpPr>
+          <p:cNvPr id="3" name="Content Placeholder 2"/>
+          <p:cNvSpPr>
+            <a:spLocks noGrp="1"/>
+          </p:cNvSpPr>
+          <p:nvPr>
+            <p:ph idx="1"/>
+          </p:nvPr>
+        </p:nvSpPr>
+        <p:spPr/>
+        <p:txBody>
+          <a:bodyPr/>
+          <a:lstStyle/>
+          <a:p>
+            <a:pPr>
+              <a:defRPr sz="1600"/>
+            </a:pPr>
+            <a:r>
+              <a:t>Lynch et al. 2015. Cell Reports. Elephantid genomes and Arctic adaptation. DOI 10.1016/j.celrep.2015.06.027</a:t>
+            </a:r>
+          </a:p>
+          <a:p>
+            <a:pPr>
+              <a:defRPr sz="1600"/>
+            </a:pPr>
+            <a:r>
+              <a:t>Lu et al. 2010. Current Biology. Reindeer circadian attenuation. DOI 10.1016/j.cub.2010.01.042</a:t>
+            </a:r>
+          </a:p>
+          <a:p>
+            <a:pPr>
+              <a:defRPr sz="1600"/>
+            </a:pPr>
+            <a:r>
+              <a:t>Zimov et al. 2012. Quaternary Science Reviews. Mammoth steppe productivity. DOI 10.1016/j.quascirev.2012.08.004</a:t>
+            </a:r>
+          </a:p>
+          <a:p>
+            <a:pPr>
+              <a:defRPr sz="1600"/>
+            </a:pPr>
+            <a:r>
+              <a:t>Wooller et al. 2021. Science. Lifetime mobility of an Arctic woolly mammoth. DOI 10.1126/science.abg1134</a:t>
+            </a:r>
+          </a:p>
+          <a:p>
+            <a:pPr>
+              <a:defRPr sz="1600"/>
+            </a:pPr>
+            <a:r>
+              <a:t>Nogues-Bravo et al. 2008. PLoS Biology. Climate, humans, and mammoth extinction. DOI 10.1371/journal.pbio.0060079</a:t>
+            </a:r>
+          </a:p>
+        </p:txBody>
+      </p:sp>
+    </p:spTree>
+  </p:cSld>
+  <p:clrMapOvr>
+    <a:masterClrMapping/>
+  </p:clrMapOvr>
+</p:sld>
+</file>
+
+<file path=ppt/slides/slide18.xml><?xml version="1.0" encoding="utf-8"?>
+<p:sld xmlns:a="http://schemas.openxmlformats.org/drawingml/2006/main" xmlns:p="http://schemas.openxmlformats.org/presentationml/2006/main" xmlns:r="http://schemas.openxmlformats.org/officeDocument/2006/relationships">
+  <p:cSld>
+    <p:spTree>
+      <p:nvGrpSpPr>
+        <p:cNvPr id="1" name=""/>
+        <p:cNvGrpSpPr/>
+        <p:nvPr/>
+      </p:nvGrpSpPr>
+      <p:grpSpPr/>
+      <p:sp>
+        <p:nvSpPr>
+          <p:cNvPr id="2" name="Title 1"/>
+          <p:cNvSpPr>
+            <a:spLocks noGrp="1"/>
+          </p:cNvSpPr>
+          <p:nvPr>
+            <p:ph type="title"/>
+          </p:nvPr>
+        </p:nvSpPr>
+        <p:spPr/>
+        <p:txBody>
+          <a:bodyPr/>
+          <a:lstStyle/>
+          <a:p>
+            <a:r>
+              <a:t>Key literature - thylacine dossier &amp; sovereignty</a:t>
+            </a:r>
+          </a:p>
+        </p:txBody>
+      </p:sp>
+      <p:sp>
+        <p:nvSpPr>
+          <p:cNvPr id="3" name="Content Placeholder 2"/>
+          <p:cNvSpPr>
+            <a:spLocks noGrp="1"/>
+          </p:cNvSpPr>
+          <p:nvPr>
+            <p:ph idx="1"/>
+          </p:nvPr>
+        </p:nvSpPr>
+        <p:spPr/>
+        <p:txBody>
+          <a:bodyPr/>
+          <a:lstStyle/>
+          <a:p>
+            <a:pPr>
+              <a:defRPr sz="1600"/>
+            </a:pPr>
+            <a:r>
+              <a:t>Pozniak et al. 2018. Orbit / skull morphology and diel activity. DOI 10.1002/ar.23910</a:t>
+            </a:r>
+          </a:p>
+          <a:p>
+            <a:pPr>
+              <a:defRPr sz="1600"/>
+            </a:pPr>
+            <a:r>
+              <a:t>Mass &amp; Supin 2020. RGC topography methods. DOI 10.31857/S0002332920060107 [Interpolated in thylacine POV]</a:t>
+            </a:r>
+          </a:p>
+          <a:p>
+            <a:pPr>
+              <a:defRPr sz="1600"/>
+            </a:pPr>
+            <a:r>
+              <a:t>Paddle 2000. The Last Tasmanian Tiger. ISBN 9780521782196</a:t>
+            </a:r>
+          </a:p>
+          <a:p>
+            <a:pPr>
+              <a:defRPr sz="1600"/>
+            </a:pPr>
+            <a:r>
+              <a:t>Sleightholme &amp; Campbell 2016. Human pressures and extinction framing. DOI 10.1080/00222933.2016.1217037</a:t>
+            </a:r>
+          </a:p>
+          <a:p>
+            <a:pPr>
+              <a:defRPr sz="1600"/>
+            </a:pPr>
+            <a:r>
+              <a:t>Clements 2025. DOI 10.1177/13534858251272203 | Rimmer 2020 Artlink | Lehman 2013 Griffith Review | Schlunke 2025 DOI 10.1017/ext.2025.10008</a:t>
+            </a:r>
+          </a:p>
+        </p:txBody>
+      </p:sp>
+    </p:spTree>
+  </p:cSld>
+  <p:clrMapOvr>
+    <a:masterClrMapping/>
+  </p:clrMapOvr>
+</p:sld>
+</file>
+
+<file path=ppt/slides/slide19.xml><?xml version="1.0" encoding="utf-8"?>
+<p:sld xmlns:a="http://schemas.openxmlformats.org/drawingml/2006/main" xmlns:p="http://schemas.openxmlformats.org/presentationml/2006/main" xmlns:r="http://schemas.openxmlformats.org/officeDocument/2006/relationships">
+  <p:cSld>
+    <p:spTree>
+      <p:nvGrpSpPr>
+        <p:cNvPr id="1" name=""/>
+        <p:cNvGrpSpPr/>
+        <p:nvPr/>
+      </p:nvGrpSpPr>
+      <p:grpSpPr/>
+      <p:sp>
+        <p:nvSpPr>
+          <p:cNvPr id="2" name="Title 1"/>
+          <p:cNvSpPr>
+            <a:spLocks noGrp="1"/>
+          </p:cNvSpPr>
+          <p:nvPr>
+            <p:ph type="title"/>
+          </p:nvPr>
+        </p:nvSpPr>
+        <p:spPr/>
+        <p:txBody>
+          <a:bodyPr/>
+          <a:lstStyle/>
+          <a:p>
+            <a:r>
+              <a:t>Limitations &amp; honest reflection</a:t>
+            </a:r>
+          </a:p>
+        </p:txBody>
+      </p:sp>
+      <p:sp>
+        <p:nvSpPr>
+          <p:cNvPr id="3" name="Content Placeholder 2"/>
+          <p:cNvSpPr>
+            <a:spLocks noGrp="1"/>
+          </p:cNvSpPr>
+          <p:nvPr>
+            <p:ph idx="1"/>
+          </p:nvPr>
+        </p:nvSpPr>
+        <p:spPr/>
+        <p:txBody>
+          <a:bodyPr/>
+          <a:lstStyle/>
+          <a:p>
+            <a:pPr>
+              <a:defRPr sz="1600"/>
+            </a:pPr>
+            <a:r>
+              <a:t>No living mammoth or thylacine: all sensory reconstruction is partial, bounded, and explicitly tiered.</a:t>
+            </a:r>
+          </a:p>
+          <a:p>
+            <a:pPr>
+              <a:defRPr sz="1600"/>
+            </a:pPr>
+            <a:r>
+              <a:t>Generative media can feel real, so the deck and UI design against deceptive realism.</a:t>
+            </a:r>
+          </a:p>
+          <a:p>
+            <a:pPr>
+              <a:defRPr sz="1600"/>
+            </a:pPr>
+            <a:r>
+              <a:t>Two people / short sprint means narrow but deep: one strong integrated experience beats many weak scenes.</a:t>
+            </a:r>
+          </a:p>
+          <a:p>
+            <a:pPr>
+              <a:defRPr sz="1600"/>
+            </a:pPr>
+            <a:r>
+              <a:t>Desktop WebXR path is canonical; any AR or mobile path is supportive rather than mission-critical.</a:t>
             </a:r>
           </a:p>
         </p:txBody>
@@ -3941,23 +4112,175 @@
               <a:defRPr sz="1600"/>
             </a:pPr>
             <a:r>
-              <a:t>Team: GUO XIAO YUE - ID MC569254</a:t>
-            </a:r>
-          </a:p>
-          <a:p>
-            <a:pPr>
-              <a:defRPr sz="1600"/>
-            </a:pPr>
-            <a:r>
-              <a:t>Team: LIU JIA QUN - ID MC569293</a:t>
-            </a:r>
-          </a:p>
-          <a:p>
-            <a:pPr>
-              <a:defRPr sz="1600"/>
-            </a:pPr>
-            <a:r>
-              <a:t>Program: MDes - Digital Art &amp; AI Technology</a:t>
+              <a:t>GUO XIAO YUE - MC569254</a:t>
+            </a:r>
+          </a:p>
+          <a:p>
+            <a:pPr>
+              <a:defRPr sz="1600"/>
+            </a:pPr>
+            <a:r>
+              <a:t>LIU JIA QUN - MC569293</a:t>
+            </a:r>
+          </a:p>
+          <a:p>
+            <a:pPr>
+              <a:defRPr sz="1600"/>
+            </a:pPr>
+            <a:r>
+              <a:t>Program: Digital Art &amp; AI Technology (MDes) | 2-person team</a:t>
+            </a:r>
+          </a:p>
+        </p:txBody>
+      </p:sp>
+    </p:spTree>
+  </p:cSld>
+  <p:clrMapOvr>
+    <a:masterClrMapping/>
+  </p:clrMapOvr>
+</p:sld>
+</file>
+
+<file path=ppt/slides/slide20.xml><?xml version="1.0" encoding="utf-8"?>
+<p:sld xmlns:a="http://schemas.openxmlformats.org/drawingml/2006/main" xmlns:p="http://schemas.openxmlformats.org/presentationml/2006/main" xmlns:r="http://schemas.openxmlformats.org/officeDocument/2006/relationships">
+  <p:cSld>
+    <p:spTree>
+      <p:nvGrpSpPr>
+        <p:cNvPr id="1" name=""/>
+        <p:cNvGrpSpPr/>
+        <p:nvPr/>
+      </p:nvGrpSpPr>
+      <p:grpSpPr/>
+      <p:sp>
+        <p:nvSpPr>
+          <p:cNvPr id="2" name="Title 1"/>
+          <p:cNvSpPr>
+            <a:spLocks noGrp="1"/>
+          </p:cNvSpPr>
+          <p:nvPr>
+            <p:ph type="title"/>
+          </p:nvPr>
+        </p:nvSpPr>
+        <p:spPr/>
+        <p:txBody>
+          <a:bodyPr/>
+          <a:lstStyle/>
+          <a:p>
+            <a:r>
+              <a:t>Q&amp;A prompts we practice</a:t>
+            </a:r>
+          </a:p>
+        </p:txBody>
+      </p:sp>
+      <p:sp>
+        <p:nvSpPr>
+          <p:cNvPr id="3" name="Content Placeholder 2"/>
+          <p:cNvSpPr>
+            <a:spLocks noGrp="1"/>
+          </p:cNvSpPr>
+          <p:nvPr>
+            <p:ph idx="1"/>
+          </p:nvPr>
+        </p:nvSpPr>
+        <p:spPr/>
+        <p:txBody>
+          <a:bodyPr/>
+          <a:lstStyle/>
+          <a:p>
+            <a:pPr>
+              <a:defRPr sz="1600"/>
+            </a:pPr>
+            <a:r>
+              <a:t>Why these species and not easier icons?</a:t>
+            </a:r>
+          </a:p>
+          <a:p>
+            <a:pPr>
+              <a:defRPr sz="1600"/>
+            </a:pPr>
+            <a:r>
+              <a:t>Where is the living biology if there is no wet-lab organism on stage?</a:t>
+            </a:r>
+          </a:p>
+          <a:p>
+            <a:pPr>
+              <a:defRPr sz="1600"/>
+            </a:pPr>
+            <a:r>
+              <a:t>How do you prevent AI misinformation and overclaiming?</a:t>
+            </a:r>
+          </a:p>
+          <a:p>
+            <a:pPr>
+              <a:defRPr sz="1600"/>
+            </a:pPr>
+            <a:r>
+              <a:t>What would the next four months add: more dossiers, deeper methods, richer physical anchor, or consultant validation?</a:t>
+            </a:r>
+          </a:p>
+        </p:txBody>
+      </p:sp>
+    </p:spTree>
+  </p:cSld>
+  <p:clrMapOvr>
+    <a:masterClrMapping/>
+  </p:clrMapOvr>
+</p:sld>
+</file>
+
+<file path=ppt/slides/slide21.xml><?xml version="1.0" encoding="utf-8"?>
+<p:sld xmlns:a="http://schemas.openxmlformats.org/drawingml/2006/main" xmlns:p="http://schemas.openxmlformats.org/presentationml/2006/main" xmlns:r="http://schemas.openxmlformats.org/officeDocument/2006/relationships">
+  <p:cSld>
+    <p:spTree>
+      <p:nvGrpSpPr>
+        <p:cNvPr id="1" name=""/>
+        <p:cNvGrpSpPr/>
+        <p:nvPr/>
+      </p:nvGrpSpPr>
+      <p:grpSpPr/>
+      <p:sp>
+        <p:nvSpPr>
+          <p:cNvPr id="2" name="Title 1"/>
+          <p:cNvSpPr>
+            <a:spLocks noGrp="1"/>
+          </p:cNvSpPr>
+          <p:nvPr>
+            <p:ph type="ctrTitle"/>
+          </p:nvPr>
+        </p:nvSpPr>
+        <p:spPr/>
+        <p:txBody>
+          <a:bodyPr/>
+          <a:lstStyle/>
+          <a:p>
+            <a:r>
+              <a:t>Thank you</a:t>
+            </a:r>
+          </a:p>
+        </p:txBody>
+      </p:sp>
+      <p:sp>
+        <p:nvSpPr>
+          <p:cNvPr id="3" name="Subtitle 2"/>
+          <p:cNvSpPr>
+            <a:spLocks noGrp="1"/>
+          </p:cNvSpPr>
+          <p:nvPr>
+            <p:ph type="subTitle" idx="1"/>
+          </p:nvPr>
+        </p:nvSpPr>
+        <p:spPr/>
+        <p:txBody>
+          <a:bodyPr/>
+          <a:lstStyle/>
+          <a:p>
+            <a:r>
+              <a:t>Archive of Extinction</a:t>
+            </a:r>
+          </a:p>
+          <a:p>
+            <a:r>
+              <a:t>Questions?</a:t>
             </a:r>
           </a:p>
         </p:txBody>
@@ -3996,7 +4319,7 @@
           <a:lstStyle/>
           <a:p>
             <a:r>
-              <a:t>Title rationale (for judges)</a:t>
+              <a:t>Why this project now</a:t>
             </a:r>
           </a:p>
         </p:txBody>
@@ -4020,23 +4343,23 @@
               <a:defRPr sz="1600"/>
             </a:pPr>
             <a:r>
-              <a:t>Archive of Extinction: names the loss of species and of their temporal niches.</a:t>
-            </a:r>
-          </a:p>
-          <a:p>
-            <a:pPr>
-              <a:defRPr sz="1600"/>
-            </a:pPr>
-            <a:r>
-              <a:t>Environmental Hypothesis Dossiers: each scene is a testable claim about Umwelt + habitat, tied to papers.</a:t>
-            </a:r>
-          </a:p>
-          <a:p>
-            <a:pPr>
-              <a:defRPr sz="1600"/>
-            </a:pPr>
-            <a:r>
-              <a:t>AI memorial + sensory time capsule: generative WebXR makes rhythm and sensation discussable, not only images.</a:t>
+              <a:t>Extinction removes more than bodies: it erases routes, light-dark entrainment, social synchrony, and sensory fit to landscape.</a:t>
+            </a:r>
+          </a:p>
+          <a:p>
+            <a:pPr>
+              <a:defRPr sz="1600"/>
+            </a:pPr>
+            <a:r>
+              <a:t>Public memory normalizes ecological absence into icons; science stays in papers while loss becomes abstract.</a:t>
+            </a:r>
+          </a:p>
+          <a:p>
+            <a:pPr>
+              <a:defRPr sz="1600"/>
+            </a:pPr>
+            <a:r>
+              <a:t>Design question: how do we make rigorous biology feelable without pretending we fully know another species' Umwelt?</a:t>
             </a:r>
           </a:p>
         </p:txBody>
@@ -4075,7 +4398,7 @@
           <a:lstStyle/>
           <a:p>
             <a:r>
-              <a:t>Biodesign Challenge 2026</a:t>
+              <a:t>Project thesis</a:t>
             </a:r>
           </a:p>
         </p:txBody>
@@ -4099,31 +4422,23 @@
               <a:defRPr sz="1600"/>
             </a:pPr>
             <a:r>
-              <a:t>Intersection of biotechnology, art, and design; Summit + MoMA judging for finalists.</a:t>
-            </a:r>
-          </a:p>
-          <a:p>
-            <a:pPr>
-              <a:defRPr sz="1600"/>
-            </a:pPr>
-            <a:r>
-              <a:t>Gallery theme: "Convergent Life." We target Biodigital Excellence + Narrative, Context, Reflection.</a:t>
-            </a:r>
-          </a:p>
-          <a:p>
-            <a:pPr>
-              <a:defRPr sz="1600"/>
-            </a:pPr>
-            <a:r>
-              <a:t>Judging: Narrative, Concept, Context, Reflection (each /4; strong tier ~2.75+).</a:t>
-            </a:r>
-          </a:p>
-          <a:p>
-            <a:pPr>
-              <a:defRPr sz="1600"/>
-            </a:pPr>
-            <a:r>
-              <a:t>biodesignchallenge.org/judging | /prizes</a:t>
+              <a:t>Archive of Extinction is a browser-first biodesign memorial that reconstructs a bounded sensory-temporal hypothesis space for extinct species.</a:t>
+            </a:r>
+          </a:p>
+          <a:p>
+            <a:pPr>
+              <a:defRPr sz="1600"/>
+            </a:pPr>
+            <a:r>
+              <a:t>It is grounded in citable research, expressed through WebXR, controlled generative passes, and optional Web Audio.</a:t>
+            </a:r>
+          </a:p>
+          <a:p>
+            <a:pPr>
+              <a:defRPr sz="1600"/>
+            </a:pPr>
+            <a:r>
+              <a:t>The experience closes with evidence literacy and branching ethics so digital recall never erases conservation urgency.</a:t>
             </a:r>
           </a:p>
         </p:txBody>
@@ -4162,7 +4477,7 @@
           <a:lstStyle/>
           <a:p>
             <a:r>
-              <a:t>Core research proposition</a:t>
+              <a:t>Scope &amp; title logic</a:t>
             </a:r>
           </a:p>
         </p:txBody>
@@ -4186,23 +4501,31 @@
               <a:defRPr sz="1600"/>
             </a:pPr>
             <a:r>
-              <a:t>If we use generative AI + WebXR to reconstruct and visualize temporal phenotypes of extinct species,</a:t>
-            </a:r>
-          </a:p>
-          <a:p>
-            <a:pPr>
-              <a:defRPr sz="1600"/>
-            </a:pPr>
-            <a:r>
-              <a:t>can we repair the human gap in sensing extinction - the loss of another species' time, not only its image?</a:t>
-            </a:r>
-          </a:p>
-          <a:p>
-            <a:pPr>
-              <a:defRPr sz="1600"/>
-            </a:pPr>
-            <a:r>
-              <a:t>Intersection statement from ideation workbook, stress-tested against the BDC rubric.</a:t>
+              <a:t>Main title foregrounds extinction and remembrance: this is not de-extinction marketing.</a:t>
+            </a:r>
+          </a:p>
+          <a:p>
+            <a:pPr>
+              <a:defRPr sz="1600"/>
+            </a:pPr>
+            <a:r>
+              <a:t>“Umwelt Hypothesis Dossiers” signals that each species is a folder of testable claims, not a fantasy safari.</a:t>
+            </a:r>
+          </a:p>
+          <a:p>
+            <a:pPr>
+              <a:defRPr sz="1600"/>
+            </a:pPr>
+            <a:r>
+              <a:t>“Sensory Time Capsule” emphasizes temporal niche - how a species lived in day, season, synchrony, and atmosphere.</a:t>
+            </a:r>
+          </a:p>
+          <a:p>
+            <a:pPr>
+              <a:defRPr sz="1600"/>
+            </a:pPr>
+            <a:r>
+              <a:t>Locked scope: two deep dossiers only - woolly mammoth + thylacine.</a:t>
             </a:r>
           </a:p>
         </p:txBody>
@@ -4241,7 +4564,7 @@
           <a:lstStyle/>
           <a:p>
             <a:r>
-              <a:t>Conceptual methods</a:t>
+              <a:t>Core architecture</a:t>
             </a:r>
           </a:p>
         </p:txBody>
@@ -4265,31 +4588,23 @@
               <a:defRPr sz="1600"/>
             </a:pPr>
             <a:r>
-              <a:t>Palaeo-chronobiology: infer day/year phase from genomics, photoperiod proxies, morphology (orbit, channels).</a:t>
-            </a:r>
-          </a:p>
-          <a:p>
-            <a:pPr>
-              <a:defRPr sz="1600"/>
-            </a:pPr>
-            <a:r>
-              <a:t>Temporal niche: extinction as erasure of shared ecological time, not only DNA.</a:t>
-            </a:r>
-          </a:p>
-          <a:p>
-            <a:pPr>
-              <a:defRPr sz="1600"/>
-            </a:pPr>
-            <a:r>
-              <a:t>Umwelt (von Uexkull): model sensory worlds as hypotheses - never silent speculation.</a:t>
-            </a:r>
-          </a:p>
-          <a:p>
-            <a:pPr>
-              <a:defRPr sz="1600"/>
-            </a:pPr>
-            <a:r>
-              <a:t>Red-flag test: if biology OR code is removed and the project still works, we failed biodesign or our digital edge.</a:t>
+              <a:t>Dossier: evidence cards, temporal niche, sensory proxies, extinction mechanism, constrained 360 scene.</a:t>
+            </a:r>
+          </a:p>
+          <a:p>
+            <a:pPr>
+              <a:defRPr sz="1600"/>
+            </a:pPr>
+            <a:r>
+              <a:t>Mixer: seasonal layers, diel rhythm, coexistence density, harmony -&gt; conflict as sonic / temporal retuning.</a:t>
+            </a:r>
+          </a:p>
+          <a:p>
+            <a:pPr>
+              <a:defRPr sz="1600"/>
+            </a:pPr>
+            <a:r>
+              <a:t>Ethics console: evidence gate + branching trade-offs around conservation, law, ecosystem risk, and sovereignty.</a:t>
             </a:r>
           </a:p>
         </p:txBody>
@@ -4328,7 +4643,7 @@
           <a:lstStyle/>
           <a:p>
             <a:r>
-              <a:t>Design techniques &amp; stack</a:t>
+              <a:t>Biological layer</a:t>
             </a:r>
           </a:p>
         </p:txBody>
@@ -4352,47 +4667,23 @@
               <a:defRPr sz="1600"/>
             </a:pPr>
             <a:r>
-              <a:t>WebXR: A-Frame / Three.js; immersive dossier navigation.</a:t>
-            </a:r>
-          </a:p>
-          <a:p>
-            <a:pPr>
-              <a:defRPr sz="1600"/>
-            </a:pPr>
-            <a:r>
-              <a:t>Generative environments: constrained by paleo proxies (Zimov steppe, seasonal light) - not fantasy biomes.</a:t>
-            </a:r>
-          </a:p>
-          <a:p>
-            <a:pPr>
-              <a:defRPr sz="1600"/>
-            </a:pPr>
-            <a:r>
-              <a:t>Time scrubber: polar day/night, season; sonification of phase (optional).</a:t>
-            </a:r>
-          </a:p>
-          <a:p>
-            <a:pPr>
-              <a:defRPr sz="1600"/>
-            </a:pPr>
-            <a:r>
-              <a:t>Epistemic UI: Cited / Interpolated / Speculative toggles + on-screen (Author, year) tags per scene ID.</a:t>
-            </a:r>
-          </a:p>
-          <a:p>
-            <a:pPr>
-              <a:defRPr sz="1600"/>
-            </a:pPr>
-            <a:r>
-              <a:t>Ethics fork: resource sliders after Sherkow &amp; Greely (2013); Indigenous context UI with Palawa-first citations.</a:t>
-            </a:r>
-          </a:p>
-          <a:p>
-            <a:pPr>
-              <a:defRPr sz="1600"/>
-            </a:pPr>
-            <a:r>
-              <a:t>Reflection: templates/reflection-log-webxr.html - keyword match to ethics themes (heuristic, auditable).</a:t>
+              <a:t>Only traceable evidence enters the archive: tusk isotopes, comparative genomics, morphology as sensory proxy, historical ecology, and acoustic relatives.</a:t>
+            </a:r>
+          </a:p>
+          <a:p>
+            <a:pPr>
+              <a:defRPr sz="1600"/>
+            </a:pPr>
+            <a:r>
+              <a:t>Every strong claim is tagged Cited, Interpolated / Modeled, or Speculative.</a:t>
+            </a:r>
+          </a:p>
+          <a:p>
+            <a:pPr>
+              <a:defRPr sz="1600"/>
+            </a:pPr>
+            <a:r>
+              <a:t>Mammoth copy is locked to “circadian-related genes” until full-text PER2 confirmation exists.</a:t>
             </a:r>
           </a:p>
         </p:txBody>
@@ -4431,7 +4722,7 @@
           <a:lstStyle/>
           <a:p>
             <a:r>
-              <a:t>Ideation process (8 steps)</a:t>
+              <a:t>Digital layer &amp; design techniques</a:t>
             </a:r>
           </a:p>
         </p:txBody>
@@ -4455,23 +4746,31 @@
               <a:defRPr sz="1600"/>
             </a:pPr>
             <a:r>
-              <a:t>1 Map skills - 2 Intersection statements - 3 Rubric stress-test - 4 Biology literature sprints</a:t>
-            </a:r>
-          </a:p>
-          <a:p>
-            <a:pPr>
-              <a:defRPr sz="1600"/>
-            </a:pPr>
-            <a:r>
-              <a:t>5 Bio/digital split - 6 Narrative draft - 7 Prototype + BDC deliverables - 8 Build + polish + Q&amp;A</a:t>
-            </a:r>
-          </a:p>
-          <a:p>
-            <a:pPr>
-              <a:defRPr sz="1600"/>
-            </a:pPr>
-            <a:r>
-              <a:t>Aligned with biodesign_cursor_agent.md + course workbook.</a:t>
+              <a:t>WebXR stack: A-Frame / Three.js with desktop fallback; minimal QR-linked physical anchor for summit reliability.</a:t>
+            </a:r>
+          </a:p>
+          <a:p>
+            <a:pPr>
+              <a:defRPr sz="1600"/>
+            </a:pPr>
+            <a:r>
+              <a:t>Generative image strategy: control-first passes, procedural atmosphere, and palette / sun rules bounded by paleo proxies.</a:t>
+            </a:r>
+          </a:p>
+          <a:p>
+            <a:pPr>
+              <a:defRPr sz="1600"/>
+            </a:pPr>
+            <a:r>
+              <a:t>Time scrubber, sonification / Web Audio, and on-screen citation tags turn atmosphere into argument rather than decoration.</a:t>
+            </a:r>
+          </a:p>
+          <a:p>
+            <a:pPr>
+              <a:defRPr sz="1600"/>
+            </a:pPr>
+            <a:r>
+              <a:t>Reflection UI uses auditable heuristics, not opaque LLM outputs, to compare viewer input with ethics themes.</a:t>
             </a:r>
           </a:p>
         </p:txBody>
@@ -4510,7 +4809,7 @@
           <a:lstStyle/>
           <a:p>
             <a:r>
-              <a:t>Design sprint (4 weeks)</a:t>
+              <a:t>Two species - two dossiers</a:t>
             </a:r>
           </a:p>
         </p:txBody>
@@ -4522,43 +4821,91 @@
             <a:spLocks noGrp="1"/>
           </p:cNvSpPr>
           <p:nvPr>
-            <p:ph idx="1"/>
-          </p:nvPr>
-        </p:nvSpPr>
-        <p:spPr/>
-        <p:txBody>
-          <a:bodyPr/>
-          <a:lstStyle/>
-          <a:p>
-            <a:pPr>
-              <a:defRPr sz="1600"/>
-            </a:pPr>
-            <a:r>
-              <a:t>W1 Discovery: citation grid, storyboard Scene_* IDs, WebXR shell.</a:t>
-            </a:r>
-          </a:p>
-          <a:p>
-            <a:pPr>
-              <a:defRPr sz="1600"/>
-            </a:pPr>
-            <a:r>
-              <a:t>W2 Prototype: time axis, generative pipeline doc, epistemic wireframes.</a:t>
-            </a:r>
-          </a:p>
-          <a:p>
-            <a:pPr>
-              <a:defRPr sz="1600"/>
-            </a:pPr>
-            <a:r>
-              <a:t>W3 Integration: sonification, UI_Ethics_Fork, UI_Indigenous_Context, reflection panel.</a:t>
-            </a:r>
-          </a:p>
-          <a:p>
-            <a:pPr>
-              <a:defRPr sz="1600"/>
-            </a:pPr>
-            <a:r>
-              <a:t>W4 Polish: 10+5 min rehearsal, creative video, deploy, judge one-sheet.</a:t>
+            <p:ph idx="1" sz="half"/>
+          </p:nvPr>
+        </p:nvSpPr>
+        <p:spPr/>
+        <p:txBody>
+          <a:bodyPr/>
+          <a:lstStyle/>
+          <a:p>
+            <a:pPr>
+              <a:defRPr b="1" sz="1400"/>
+            </a:pPr>
+            <a:r>
+              <a:t>Woolly mammoth</a:t>
+            </a:r>
+          </a:p>
+          <a:p>
+            <a:pPr>
+              <a:defRPr sz="1300"/>
+            </a:pPr>
+            <a:r>
+              <a:t>Hero species for Arctic rhythm, mammoth-steppe atmosphere, and de-extinction pressure.</a:t>
+            </a:r>
+          </a:p>
+          <a:p>
+            <a:pPr>
+              <a:defRPr sz="1300"/>
+            </a:pPr>
+            <a:r>
+              <a:t>Lynch 2015 circadian-related genes; Lu 2010 reindeer analogy [Interpolated]; Zimov 2012 habitat pulse.</a:t>
+            </a:r>
+          </a:p>
+          <a:p>
+            <a:pPr>
+              <a:defRPr sz="1300"/>
+            </a:pPr>
+            <a:r>
+              <a:t>Additional anchors: Wooller 2021 tusk isotope mobility; Nogues-Bravo 2008 climate x human extinction context.</a:t>
+            </a:r>
+          </a:p>
+        </p:txBody>
+      </p:sp>
+      <p:sp>
+        <p:nvSpPr>
+          <p:cNvPr id="4" name="Content Placeholder 3"/>
+          <p:cNvSpPr>
+            <a:spLocks noGrp="1"/>
+          </p:cNvSpPr>
+          <p:nvPr>
+            <p:ph idx="2" sz="half"/>
+          </p:nvPr>
+        </p:nvSpPr>
+        <p:spPr/>
+        <p:txBody>
+          <a:bodyPr/>
+          <a:lstStyle/>
+          <a:p>
+            <a:pPr>
+              <a:defRPr b="1" sz="1400"/>
+            </a:pPr>
+            <a:r>
+              <a:t>Thylacine</a:t>
+            </a:r>
+          </a:p>
+          <a:p>
+            <a:pPr>
+              <a:defRPr sz="1300"/>
+            </a:pPr>
+            <a:r>
+              <a:t>Structural echo for crepuscular vision, colonial memory, and cultural sovereignty.</a:t>
+            </a:r>
+          </a:p>
+          <a:p>
+            <a:pPr>
+              <a:defRPr sz="1300"/>
+            </a:pPr>
+            <a:r>
+              <a:t>Pozniak 2018 orbit / diel activity; Mass &amp; Supin 2020 RGC methods [Interpolated]; Paddle 2000; Sleightholme &amp; Campbell 2016.</a:t>
+            </a:r>
+          </a:p>
+          <a:p>
+            <a:pPr>
+              <a:defRPr sz="1300"/>
+            </a:pPr>
+            <a:r>
+              <a:t>T5 context: Clements 2025 plus Palawa-led / centered Rimmer 2020, Lehman 2013, and Schlunke 2025.</a:t>
             </a:r>
           </a:p>
         </p:txBody>

</xml_diff>